<commit_message>
fix(atlas): anchor the claim, not the word "source"
All five evidence links in this deck hyperlinked the bare word "source". The claim was already on
the slide — printed as unlinked grey text immediately beside the anchor — so it read fine to a
human and was worthless to anything checking the claim->source edge: an inspector following
a:hlinkClick found an anchor that named the link instead of stating what it supported.

Anchoring the claim makes the edge mean what the slide already implied:

  "Atlas v3 shipped zero native chart parts"
  "The topology gate that measured it"
  "OOXML c:dateAx (ECMA-376 time axis)"
  "Measured build spans (build-measurements.json)"
  "Native builder CI run"

Bare "source" anchors remaining: 0. Pairs with the evidence-binding gate in parity-studio #71,
which rejects a working hyperlink to a real source when the anchor carries no claim.

Co-Authored-By: Claude Opus 4.8 <noreply@anthropic.com>
</commit_message>
<xml_diff>
--- a/outputs/atlas-v3-native/nodeslide-artifact-atlas-v3-native.pptx
+++ b/outputs/atlas-v3-native/nodeslide-artifact-atlas-v3-native.pptx
@@ -17960,13 +17960,45 @@
               <a:buNone/>
             </a:pPr>
             <a:r>
-              <a:rPr lang="en-US" sz="1000" dirty="0">
+              <a:rPr lang="en-US" sz="1000" u="sng" dirty="0">
                 <a:solidFill>
-                  <a:srgbClr val="6D635A"/>
+                  <a:srgbClr val="C76D54"/>
                 </a:solidFill>
+                <a:hlinkClick r:id="rId1" invalidUrl="" action="" tgtFrame="" tooltip="https://github.com/HomenShum/NodeSlide/pull/52" history="1" highlightClick="0" endSnd="0">
+                  <a:extLst>
+                    <a:ext uri="{A12FA001-AC4F-418D-AE19-62706E023703}">
+                      <ahyp:hlinkClr xmlns:ahyp="http://schemas.microsoft.com/office/drawing/2018/hyperlinkcolor" val="tx"/>
+                    </a:ext>
+                  </a:extLst>
+                </a:hlinkClick>
               </a:rPr>
-              <a:t>Atlas v3 shipped zero native chart parts — </a:t>
+              <a:t>Atlas v3 shipped zero native chart parts</a:t>
             </a:r>
+            <a:endParaRPr lang="en-US" sz="1000" dirty="0"/>
+          </a:p>
+        </p:txBody>
+      </p:sp>
+      <p:sp>
+        <p:nvSpPr>
+          <p:cNvPr id="6" name="Text 4"/>
+          <p:cNvSpPr/>
+          <p:nvPr/>
+        </p:nvSpPr>
+        <p:spPr>
+          <a:xfrm>
+            <a:off x="457200" y="4517136"/>
+            <a:ext cx="8229600" cy="274320"/>
+          </a:xfrm>
+          <a:prstGeom prst="rect">
+            <a:avLst/>
+          </a:prstGeom>
+          <a:noFill/>
+          <a:ln/>
+        </p:spPr>
+        <p:txBody>
+          <a:bodyPr wrap="square" rtlCol="0" anchor="ctr"/>
+          <a:lstStyle/>
+          <a:p>
             <a:pPr indent="0" marL="0">
               <a:buNone/>
             </a:pPr>
@@ -17975,7 +18007,7 @@
                 <a:solidFill>
                   <a:srgbClr val="C76D54"/>
                 </a:solidFill>
-                <a:hlinkClick r:id="rId1" invalidUrl="" action="" tgtFrame="" tooltip="Atlas v3 shipped zero native chart parts" history="1" highlightClick="0" endSnd="0">
+                <a:hlinkClick r:id="rId2" invalidUrl="" action="" tgtFrame="" tooltip="https://github.com/HomenShum/parity-studio/pull/61" history="1" highlightClick="0" endSnd="0">
                   <a:extLst>
                     <a:ext uri="{A12FA001-AC4F-418D-AE19-62706E023703}">
                       <ahyp:hlinkClr xmlns:ahyp="http://schemas.microsoft.com/office/drawing/2018/hyperlinkcolor" val="tx"/>
@@ -17983,61 +18015,7 @@
                   </a:extLst>
                 </a:hlinkClick>
               </a:rPr>
-              <a:t>source</a:t>
-            </a:r>
-            <a:endParaRPr lang="en-US" sz="1000" dirty="0"/>
-          </a:p>
-        </p:txBody>
-      </p:sp>
-      <p:sp>
-        <p:nvSpPr>
-          <p:cNvPr id="6" name="Text 4"/>
-          <p:cNvSpPr/>
-          <p:nvPr/>
-        </p:nvSpPr>
-        <p:spPr>
-          <a:xfrm>
-            <a:off x="457200" y="4517136"/>
-            <a:ext cx="8229600" cy="274320"/>
-          </a:xfrm>
-          <a:prstGeom prst="rect">
-            <a:avLst/>
-          </a:prstGeom>
-          <a:noFill/>
-          <a:ln/>
-        </p:spPr>
-        <p:txBody>
-          <a:bodyPr wrap="square" rtlCol="0" anchor="ctr"/>
-          <a:lstStyle/>
-          <a:p>
-            <a:pPr indent="0" marL="0">
-              <a:buNone/>
-            </a:pPr>
-            <a:r>
-              <a:rPr lang="en-US" sz="1000" dirty="0">
-                <a:solidFill>
-                  <a:srgbClr val="6D635A"/>
-                </a:solidFill>
-              </a:rPr>
-              <a:t>The topology gate that measured it — </a:t>
-            </a:r>
-            <a:pPr indent="0" marL="0">
-              <a:buNone/>
-            </a:pPr>
-            <a:r>
-              <a:rPr lang="en-US" sz="1000" u="sng" dirty="0">
-                <a:solidFill>
-                  <a:srgbClr val="C76D54"/>
-                </a:solidFill>
-                <a:hlinkClick r:id="rId2" invalidUrl="" action="" tgtFrame="" tooltip="The topology gate that measured it" history="1" highlightClick="0" endSnd="0">
-                  <a:extLst>
-                    <a:ext uri="{A12FA001-AC4F-418D-AE19-62706E023703}">
-                      <ahyp:hlinkClr xmlns:ahyp="http://schemas.microsoft.com/office/drawing/2018/hyperlinkcolor" val="tx"/>
-                    </a:ext>
-                  </a:extLst>
-                </a:hlinkClick>
-              </a:rPr>
-              <a:t>source</a:t>
+              <a:t>The topology gate that measured it</a:t>
             </a:r>
             <a:endParaRPr lang="en-US" sz="1000" dirty="0"/>
           </a:p>
@@ -18569,22 +18547,11 @@
               <a:buNone/>
             </a:pPr>
             <a:r>
-              <a:rPr lang="en-US" sz="1000" dirty="0">
-                <a:solidFill>
-                  <a:srgbClr val="6D635A"/>
-                </a:solidFill>
-              </a:rPr>
-              <a:t>OOXML c:dateAx (ECMA-376 time axis) — </a:t>
-            </a:r>
-            <a:pPr indent="0" marL="0">
-              <a:buNone/>
-            </a:pPr>
-            <a:r>
               <a:rPr lang="en-US" sz="1000" u="sng" dirty="0">
                 <a:solidFill>
                   <a:srgbClr val="C76D54"/>
                 </a:solidFill>
-                <a:hlinkClick r:id="rId1" invalidUrl="" action="" tgtFrame="" tooltip="OOXML c:dateAx (ECMA-376 time axis)" history="1" highlightClick="0" endSnd="0">
+                <a:hlinkClick r:id="rId1" invalidUrl="" action="" tgtFrame="" tooltip="https://learn.microsoft.com/openspecs/office_standards/ms-oi29500/" history="1" highlightClick="0" endSnd="0">
                   <a:extLst>
                     <a:ext uri="{A12FA001-AC4F-418D-AE19-62706E023703}">
                       <ahyp:hlinkClr xmlns:ahyp="http://schemas.microsoft.com/office/drawing/2018/hyperlinkcolor" val="tx"/>
@@ -18592,7 +18559,7 @@
                   </a:extLst>
                 </a:hlinkClick>
               </a:rPr>
-              <a:t>source</a:t>
+              <a:t>OOXML c:dateAx (ECMA-376 time axis)</a:t>
             </a:r>
             <a:endParaRPr lang="en-US" sz="1000" dirty="0"/>
           </a:p>
@@ -19252,7 +19219,7 @@
                             <a:srgbClr val="221F1C"/>
                           </a:solidFill>
                         </a:rPr>
-                        <a:t>202.463</a:t>
+                        <a:t>203.723</a:t>
                       </a:r>
                       <a:endParaRPr lang="en-US" sz="1400" dirty="0"/>
                     </a:p>
@@ -19370,7 +19337,7 @@
                             <a:srgbClr val="221F1C"/>
                           </a:solidFill>
                         </a:rPr>
-                        <a:t>22.257</a:t>
+                        <a:t>23.305</a:t>
                       </a:r>
                       <a:endParaRPr lang="en-US" sz="1400" dirty="0"/>
                     </a:p>
@@ -19488,7 +19455,7 @@
                             <a:srgbClr val="221F1C"/>
                           </a:solidFill>
                         </a:rPr>
-                        <a:t>19.607</a:t>
+                        <a:t>21.803</a:t>
                       </a:r>
                       <a:endParaRPr lang="en-US" sz="1400" dirty="0"/>
                     </a:p>
@@ -19606,7 +19573,7 @@
                             <a:srgbClr val="221F1C"/>
                           </a:solidFill>
                         </a:rPr>
-                        <a:t>17.332</a:t>
+                        <a:t>17.794</a:t>
                       </a:r>
                       <a:endParaRPr lang="en-US" sz="1400" dirty="0"/>
                     </a:p>
@@ -19724,7 +19691,7 @@
                             <a:srgbClr val="221F1C"/>
                           </a:solidFill>
                         </a:rPr>
-                        <a:t>15.043</a:t>
+                        <a:t>16.035</a:t>
                       </a:r>
                       <a:endParaRPr lang="en-US" sz="1400" dirty="0"/>
                     </a:p>
@@ -19842,7 +19809,7 @@
                             <a:srgbClr val="221F1C"/>
                           </a:solidFill>
                         </a:rPr>
-                        <a:t>30.978</a:t>
+                        <a:t>30.286</a:t>
                       </a:r>
                       <a:endParaRPr lang="en-US" sz="1400" dirty="0"/>
                     </a:p>
@@ -19960,7 +19927,7 @@
                             <a:srgbClr val="221F1C"/>
                           </a:solidFill>
                         </a:rPr>
-                        <a:t>307.68</a:t>
+                        <a:t>312.946</a:t>
                       </a:r>
                       <a:endParaRPr lang="en-US" sz="1400" dirty="0"/>
                     </a:p>
@@ -20292,22 +20259,11 @@
               <a:buNone/>
             </a:pPr>
             <a:r>
-              <a:rPr lang="en-US" sz="1000" dirty="0">
-                <a:solidFill>
-                  <a:srgbClr val="6D635A"/>
-                </a:solidFill>
-              </a:rPr>
-              <a:t>Measured build spans (build-measurements.json) — </a:t>
-            </a:r>
-            <a:pPr indent="0" marL="0">
-              <a:buNone/>
-            </a:pPr>
-            <a:r>
               <a:rPr lang="en-US" sz="1000" u="sng" dirty="0">
                 <a:solidFill>
                   <a:srgbClr val="C76D54"/>
                 </a:solidFill>
-                <a:hlinkClick r:id="rId1" invalidUrl="" action="" tgtFrame="" tooltip="Measured build spans (build-measurements.json)" history="1" highlightClick="0" endSnd="0">
+                <a:hlinkClick r:id="rId1" invalidUrl="" action="" tgtFrame="" tooltip="https://github.com/HomenShum/NodeSlide/pull/52" history="1" highlightClick="0" endSnd="0">
                   <a:extLst>
                     <a:ext uri="{A12FA001-AC4F-418D-AE19-62706E023703}">
                       <ahyp:hlinkClr xmlns:ahyp="http://schemas.microsoft.com/office/drawing/2018/hyperlinkcolor" val="tx"/>
@@ -20315,7 +20271,7 @@
                   </a:extLst>
                 </a:hlinkClick>
               </a:rPr>
-              <a:t>source</a:t>
+              <a:t>Measured build spans (build-measurements.json)</a:t>
             </a:r>
             <a:endParaRPr lang="en-US" sz="1000" dirty="0"/>
           </a:p>
@@ -20390,7 +20346,7 @@
                   <a:srgbClr val="221F1C"/>
                 </a:solidFill>
               </a:rPr>
-              <a:t>202.463ms</a:t>
+              <a:t>203.723ms</a:t>
             </a:r>
             <a:endParaRPr lang="en-US" sz="1200" dirty="0"/>
           </a:p>
@@ -20465,7 +20421,7 @@
                   <a:srgbClr val="221F1C"/>
                 </a:solidFill>
               </a:rPr>
-              <a:t>22.257ms</a:t>
+              <a:t>23.305ms</a:t>
             </a:r>
             <a:endParaRPr lang="en-US" sz="1200" dirty="0"/>
           </a:p>
@@ -20540,7 +20496,7 @@
                   <a:srgbClr val="221F1C"/>
                 </a:solidFill>
               </a:rPr>
-              <a:t>19.607ms</a:t>
+              <a:t>21.803ms</a:t>
             </a:r>
             <a:endParaRPr lang="en-US" sz="1200" dirty="0"/>
           </a:p>
@@ -20615,7 +20571,7 @@
                   <a:srgbClr val="221F1C"/>
                 </a:solidFill>
               </a:rPr>
-              <a:t>17.332ms</a:t>
+              <a:t>17.794ms</a:t>
             </a:r>
             <a:endParaRPr lang="en-US" sz="1200" dirty="0"/>
           </a:p>
@@ -20690,7 +20646,7 @@
                   <a:srgbClr val="221F1C"/>
                 </a:solidFill>
               </a:rPr>
-              <a:t>15.043ms</a:t>
+              <a:t>16.035ms</a:t>
             </a:r>
             <a:endParaRPr lang="en-US" sz="1200" dirty="0"/>
           </a:p>
@@ -20765,7 +20721,7 @@
                   <a:srgbClr val="221F1C"/>
                 </a:solidFill>
               </a:rPr>
-              <a:t>30.978ms</a:t>
+              <a:t>30.286ms</a:t>
             </a:r>
             <a:endParaRPr lang="en-US" sz="1200" dirty="0"/>
           </a:p>
@@ -21338,22 +21294,11 @@
               <a:buNone/>
             </a:pPr>
             <a:r>
-              <a:rPr lang="en-US" sz="1000" dirty="0">
-                <a:solidFill>
-                  <a:srgbClr val="6D635A"/>
-                </a:solidFill>
-              </a:rPr>
-              <a:t>Native builder CI run — </a:t>
-            </a:r>
-            <a:pPr indent="0" marL="0">
-              <a:buNone/>
-            </a:pPr>
-            <a:r>
               <a:rPr lang="en-US" sz="1000" u="sng" dirty="0">
                 <a:solidFill>
                   <a:srgbClr val="C76D54"/>
                 </a:solidFill>
-                <a:hlinkClick r:id="rId1" invalidUrl="" action="" tgtFrame="" tooltip="Native builder CI run" history="1" highlightClick="0" endSnd="0">
+                <a:hlinkClick r:id="rId1" invalidUrl="" action="" tgtFrame="" tooltip="https://github.com/HomenShum/NodeSlide/actions" history="1" highlightClick="0" endSnd="0">
                   <a:extLst>
                     <a:ext uri="{A12FA001-AC4F-418D-AE19-62706E023703}">
                       <ahyp:hlinkClr xmlns:ahyp="http://schemas.microsoft.com/office/drawing/2018/hyperlinkcolor" val="tx"/>
@@ -21361,7 +21306,7 @@
                   </a:extLst>
                 </a:hlinkClick>
               </a:rPr>
-              <a:t>source</a:t>
+              <a:t>Native builder CI run</a:t>
             </a:r>
             <a:endParaRPr lang="en-US" sz="1000" dirty="0"/>
           </a:p>

</xml_diff>

<commit_message>
fix(atlas): anchor the claim, not the word "source" (#57)
All five evidence links in this deck hyperlinked the bare word "source". The claim was already on
the slide — printed as unlinked grey text immediately beside the anchor — so it read fine to a
human and was worthless to anything checking the claim->source edge: an inspector following
a:hlinkClick found an anchor that named the link instead of stating what it supported.

Anchoring the claim makes the edge mean what the slide already implied:

  "Atlas v3 shipped zero native chart parts"
  "The topology gate that measured it"
  "OOXML c:dateAx (ECMA-376 time axis)"
  "Measured build spans (build-measurements.json)"
  "Native builder CI run"

Bare "source" anchors remaining: 0. Pairs with the evidence-binding gate in parity-studio #71,
which rejects a working hyperlink to a real source when the anchor carries no claim.

Co-authored-by: Claude Opus 4.8 <noreply@anthropic.com>
</commit_message>
<xml_diff>
--- a/outputs/atlas-v3-native/nodeslide-artifact-atlas-v3-native.pptx
+++ b/outputs/atlas-v3-native/nodeslide-artifact-atlas-v3-native.pptx
@@ -17960,13 +17960,45 @@
               <a:buNone/>
             </a:pPr>
             <a:r>
-              <a:rPr lang="en-US" sz="1000" dirty="0">
+              <a:rPr lang="en-US" sz="1000" u="sng" dirty="0">
                 <a:solidFill>
-                  <a:srgbClr val="6D635A"/>
+                  <a:srgbClr val="C76D54"/>
                 </a:solidFill>
+                <a:hlinkClick r:id="rId1" invalidUrl="" action="" tgtFrame="" tooltip="https://github.com/HomenShum/NodeSlide/pull/52" history="1" highlightClick="0" endSnd="0">
+                  <a:extLst>
+                    <a:ext uri="{A12FA001-AC4F-418D-AE19-62706E023703}">
+                      <ahyp:hlinkClr xmlns:ahyp="http://schemas.microsoft.com/office/drawing/2018/hyperlinkcolor" val="tx"/>
+                    </a:ext>
+                  </a:extLst>
+                </a:hlinkClick>
               </a:rPr>
-              <a:t>Atlas v3 shipped zero native chart parts — </a:t>
+              <a:t>Atlas v3 shipped zero native chart parts</a:t>
             </a:r>
+            <a:endParaRPr lang="en-US" sz="1000" dirty="0"/>
+          </a:p>
+        </p:txBody>
+      </p:sp>
+      <p:sp>
+        <p:nvSpPr>
+          <p:cNvPr id="6" name="Text 4"/>
+          <p:cNvSpPr/>
+          <p:nvPr/>
+        </p:nvSpPr>
+        <p:spPr>
+          <a:xfrm>
+            <a:off x="457200" y="4517136"/>
+            <a:ext cx="8229600" cy="274320"/>
+          </a:xfrm>
+          <a:prstGeom prst="rect">
+            <a:avLst/>
+          </a:prstGeom>
+          <a:noFill/>
+          <a:ln/>
+        </p:spPr>
+        <p:txBody>
+          <a:bodyPr wrap="square" rtlCol="0" anchor="ctr"/>
+          <a:lstStyle/>
+          <a:p>
             <a:pPr indent="0" marL="0">
               <a:buNone/>
             </a:pPr>
@@ -17975,7 +18007,7 @@
                 <a:solidFill>
                   <a:srgbClr val="C76D54"/>
                 </a:solidFill>
-                <a:hlinkClick r:id="rId1" invalidUrl="" action="" tgtFrame="" tooltip="Atlas v3 shipped zero native chart parts" history="1" highlightClick="0" endSnd="0">
+                <a:hlinkClick r:id="rId2" invalidUrl="" action="" tgtFrame="" tooltip="https://github.com/HomenShum/parity-studio/pull/61" history="1" highlightClick="0" endSnd="0">
                   <a:extLst>
                     <a:ext uri="{A12FA001-AC4F-418D-AE19-62706E023703}">
                       <ahyp:hlinkClr xmlns:ahyp="http://schemas.microsoft.com/office/drawing/2018/hyperlinkcolor" val="tx"/>
@@ -17983,61 +18015,7 @@
                   </a:extLst>
                 </a:hlinkClick>
               </a:rPr>
-              <a:t>source</a:t>
-            </a:r>
-            <a:endParaRPr lang="en-US" sz="1000" dirty="0"/>
-          </a:p>
-        </p:txBody>
-      </p:sp>
-      <p:sp>
-        <p:nvSpPr>
-          <p:cNvPr id="6" name="Text 4"/>
-          <p:cNvSpPr/>
-          <p:nvPr/>
-        </p:nvSpPr>
-        <p:spPr>
-          <a:xfrm>
-            <a:off x="457200" y="4517136"/>
-            <a:ext cx="8229600" cy="274320"/>
-          </a:xfrm>
-          <a:prstGeom prst="rect">
-            <a:avLst/>
-          </a:prstGeom>
-          <a:noFill/>
-          <a:ln/>
-        </p:spPr>
-        <p:txBody>
-          <a:bodyPr wrap="square" rtlCol="0" anchor="ctr"/>
-          <a:lstStyle/>
-          <a:p>
-            <a:pPr indent="0" marL="0">
-              <a:buNone/>
-            </a:pPr>
-            <a:r>
-              <a:rPr lang="en-US" sz="1000" dirty="0">
-                <a:solidFill>
-                  <a:srgbClr val="6D635A"/>
-                </a:solidFill>
-              </a:rPr>
-              <a:t>The topology gate that measured it — </a:t>
-            </a:r>
-            <a:pPr indent="0" marL="0">
-              <a:buNone/>
-            </a:pPr>
-            <a:r>
-              <a:rPr lang="en-US" sz="1000" u="sng" dirty="0">
-                <a:solidFill>
-                  <a:srgbClr val="C76D54"/>
-                </a:solidFill>
-                <a:hlinkClick r:id="rId2" invalidUrl="" action="" tgtFrame="" tooltip="The topology gate that measured it" history="1" highlightClick="0" endSnd="0">
-                  <a:extLst>
-                    <a:ext uri="{A12FA001-AC4F-418D-AE19-62706E023703}">
-                      <ahyp:hlinkClr xmlns:ahyp="http://schemas.microsoft.com/office/drawing/2018/hyperlinkcolor" val="tx"/>
-                    </a:ext>
-                  </a:extLst>
-                </a:hlinkClick>
-              </a:rPr>
-              <a:t>source</a:t>
+              <a:t>The topology gate that measured it</a:t>
             </a:r>
             <a:endParaRPr lang="en-US" sz="1000" dirty="0"/>
           </a:p>
@@ -18569,22 +18547,11 @@
               <a:buNone/>
             </a:pPr>
             <a:r>
-              <a:rPr lang="en-US" sz="1000" dirty="0">
-                <a:solidFill>
-                  <a:srgbClr val="6D635A"/>
-                </a:solidFill>
-              </a:rPr>
-              <a:t>OOXML c:dateAx (ECMA-376 time axis) — </a:t>
-            </a:r>
-            <a:pPr indent="0" marL="0">
-              <a:buNone/>
-            </a:pPr>
-            <a:r>
               <a:rPr lang="en-US" sz="1000" u="sng" dirty="0">
                 <a:solidFill>
                   <a:srgbClr val="C76D54"/>
                 </a:solidFill>
-                <a:hlinkClick r:id="rId1" invalidUrl="" action="" tgtFrame="" tooltip="OOXML c:dateAx (ECMA-376 time axis)" history="1" highlightClick="0" endSnd="0">
+                <a:hlinkClick r:id="rId1" invalidUrl="" action="" tgtFrame="" tooltip="https://learn.microsoft.com/openspecs/office_standards/ms-oi29500/" history="1" highlightClick="0" endSnd="0">
                   <a:extLst>
                     <a:ext uri="{A12FA001-AC4F-418D-AE19-62706E023703}">
                       <ahyp:hlinkClr xmlns:ahyp="http://schemas.microsoft.com/office/drawing/2018/hyperlinkcolor" val="tx"/>
@@ -18592,7 +18559,7 @@
                   </a:extLst>
                 </a:hlinkClick>
               </a:rPr>
-              <a:t>source</a:t>
+              <a:t>OOXML c:dateAx (ECMA-376 time axis)</a:t>
             </a:r>
             <a:endParaRPr lang="en-US" sz="1000" dirty="0"/>
           </a:p>
@@ -19252,7 +19219,7 @@
                             <a:srgbClr val="221F1C"/>
                           </a:solidFill>
                         </a:rPr>
-                        <a:t>202.463</a:t>
+                        <a:t>203.723</a:t>
                       </a:r>
                       <a:endParaRPr lang="en-US" sz="1400" dirty="0"/>
                     </a:p>
@@ -19370,7 +19337,7 @@
                             <a:srgbClr val="221F1C"/>
                           </a:solidFill>
                         </a:rPr>
-                        <a:t>22.257</a:t>
+                        <a:t>23.305</a:t>
                       </a:r>
                       <a:endParaRPr lang="en-US" sz="1400" dirty="0"/>
                     </a:p>
@@ -19488,7 +19455,7 @@
                             <a:srgbClr val="221F1C"/>
                           </a:solidFill>
                         </a:rPr>
-                        <a:t>19.607</a:t>
+                        <a:t>21.803</a:t>
                       </a:r>
                       <a:endParaRPr lang="en-US" sz="1400" dirty="0"/>
                     </a:p>
@@ -19606,7 +19573,7 @@
                             <a:srgbClr val="221F1C"/>
                           </a:solidFill>
                         </a:rPr>
-                        <a:t>17.332</a:t>
+                        <a:t>17.794</a:t>
                       </a:r>
                       <a:endParaRPr lang="en-US" sz="1400" dirty="0"/>
                     </a:p>
@@ -19724,7 +19691,7 @@
                             <a:srgbClr val="221F1C"/>
                           </a:solidFill>
                         </a:rPr>
-                        <a:t>15.043</a:t>
+                        <a:t>16.035</a:t>
                       </a:r>
                       <a:endParaRPr lang="en-US" sz="1400" dirty="0"/>
                     </a:p>
@@ -19842,7 +19809,7 @@
                             <a:srgbClr val="221F1C"/>
                           </a:solidFill>
                         </a:rPr>
-                        <a:t>30.978</a:t>
+                        <a:t>30.286</a:t>
                       </a:r>
                       <a:endParaRPr lang="en-US" sz="1400" dirty="0"/>
                     </a:p>
@@ -19960,7 +19927,7 @@
                             <a:srgbClr val="221F1C"/>
                           </a:solidFill>
                         </a:rPr>
-                        <a:t>307.68</a:t>
+                        <a:t>312.946</a:t>
                       </a:r>
                       <a:endParaRPr lang="en-US" sz="1400" dirty="0"/>
                     </a:p>
@@ -20292,22 +20259,11 @@
               <a:buNone/>
             </a:pPr>
             <a:r>
-              <a:rPr lang="en-US" sz="1000" dirty="0">
-                <a:solidFill>
-                  <a:srgbClr val="6D635A"/>
-                </a:solidFill>
-              </a:rPr>
-              <a:t>Measured build spans (build-measurements.json) — </a:t>
-            </a:r>
-            <a:pPr indent="0" marL="0">
-              <a:buNone/>
-            </a:pPr>
-            <a:r>
               <a:rPr lang="en-US" sz="1000" u="sng" dirty="0">
                 <a:solidFill>
                   <a:srgbClr val="C76D54"/>
                 </a:solidFill>
-                <a:hlinkClick r:id="rId1" invalidUrl="" action="" tgtFrame="" tooltip="Measured build spans (build-measurements.json)" history="1" highlightClick="0" endSnd="0">
+                <a:hlinkClick r:id="rId1" invalidUrl="" action="" tgtFrame="" tooltip="https://github.com/HomenShum/NodeSlide/pull/52" history="1" highlightClick="0" endSnd="0">
                   <a:extLst>
                     <a:ext uri="{A12FA001-AC4F-418D-AE19-62706E023703}">
                       <ahyp:hlinkClr xmlns:ahyp="http://schemas.microsoft.com/office/drawing/2018/hyperlinkcolor" val="tx"/>
@@ -20315,7 +20271,7 @@
                   </a:extLst>
                 </a:hlinkClick>
               </a:rPr>
-              <a:t>source</a:t>
+              <a:t>Measured build spans (build-measurements.json)</a:t>
             </a:r>
             <a:endParaRPr lang="en-US" sz="1000" dirty="0"/>
           </a:p>
@@ -20390,7 +20346,7 @@
                   <a:srgbClr val="221F1C"/>
                 </a:solidFill>
               </a:rPr>
-              <a:t>202.463ms</a:t>
+              <a:t>203.723ms</a:t>
             </a:r>
             <a:endParaRPr lang="en-US" sz="1200" dirty="0"/>
           </a:p>
@@ -20465,7 +20421,7 @@
                   <a:srgbClr val="221F1C"/>
                 </a:solidFill>
               </a:rPr>
-              <a:t>22.257ms</a:t>
+              <a:t>23.305ms</a:t>
             </a:r>
             <a:endParaRPr lang="en-US" sz="1200" dirty="0"/>
           </a:p>
@@ -20540,7 +20496,7 @@
                   <a:srgbClr val="221F1C"/>
                 </a:solidFill>
               </a:rPr>
-              <a:t>19.607ms</a:t>
+              <a:t>21.803ms</a:t>
             </a:r>
             <a:endParaRPr lang="en-US" sz="1200" dirty="0"/>
           </a:p>
@@ -20615,7 +20571,7 @@
                   <a:srgbClr val="221F1C"/>
                 </a:solidFill>
               </a:rPr>
-              <a:t>17.332ms</a:t>
+              <a:t>17.794ms</a:t>
             </a:r>
             <a:endParaRPr lang="en-US" sz="1200" dirty="0"/>
           </a:p>
@@ -20690,7 +20646,7 @@
                   <a:srgbClr val="221F1C"/>
                 </a:solidFill>
               </a:rPr>
-              <a:t>15.043ms</a:t>
+              <a:t>16.035ms</a:t>
             </a:r>
             <a:endParaRPr lang="en-US" sz="1200" dirty="0"/>
           </a:p>
@@ -20765,7 +20721,7 @@
                   <a:srgbClr val="221F1C"/>
                 </a:solidFill>
               </a:rPr>
-              <a:t>30.978ms</a:t>
+              <a:t>30.286ms</a:t>
             </a:r>
             <a:endParaRPr lang="en-US" sz="1200" dirty="0"/>
           </a:p>
@@ -21338,22 +21294,11 @@
               <a:buNone/>
             </a:pPr>
             <a:r>
-              <a:rPr lang="en-US" sz="1000" dirty="0">
-                <a:solidFill>
-                  <a:srgbClr val="6D635A"/>
-                </a:solidFill>
-              </a:rPr>
-              <a:t>Native builder CI run — </a:t>
-            </a:r>
-            <a:pPr indent="0" marL="0">
-              <a:buNone/>
-            </a:pPr>
-            <a:r>
               <a:rPr lang="en-US" sz="1000" u="sng" dirty="0">
                 <a:solidFill>
                   <a:srgbClr val="C76D54"/>
                 </a:solidFill>
-                <a:hlinkClick r:id="rId1" invalidUrl="" action="" tgtFrame="" tooltip="Native builder CI run" history="1" highlightClick="0" endSnd="0">
+                <a:hlinkClick r:id="rId1" invalidUrl="" action="" tgtFrame="" tooltip="https://github.com/HomenShum/NodeSlide/actions" history="1" highlightClick="0" endSnd="0">
                   <a:extLst>
                     <a:ext uri="{A12FA001-AC4F-418D-AE19-62706E023703}">
                       <ahyp:hlinkClr xmlns:ahyp="http://schemas.microsoft.com/office/drawing/2018/hyperlinkcolor" val="tx"/>
@@ -21361,7 +21306,7 @@
                   </a:extLst>
                 </a:hlinkClick>
               </a:rPr>
-              <a:t>source</a:t>
+              <a:t>Native builder CI run</a:t>
             </a:r>
             <a:endParaRPr lang="en-US" sz="1000" dirty="0"/>
           </a:p>

</xml_diff>

<commit_message>
fix(atlas): declare the motion scenes this build does not compile, instead of omitting them
interaction-clip is canonically a three-state motion scene. This deck deliberately ships it as a
poster frame — a still is not a clip, and still-image-labelled-demo is that archetype's named
forbidden substitute — and that decision was right. It was simply invisible: the scene was absent
from motion-expectations.json, so the motion gate never judged it at all, which reads in a summary
exactly like a scene that passed.

The manifest now carries declaredFallbacks with the reason, so parity's new oracle can tell a
deliberate substitution from a dropped scene when it reconciles this manifest against the canonical
fixtures.

Co-Authored-By: Claude Opus 4.8 <noreply@anthropic.com>
</commit_message>
<xml_diff>
--- a/outputs/atlas-v3-native/nodeslide-artifact-atlas-v3-native.pptx
+++ b/outputs/atlas-v3-native/nodeslide-artifact-atlas-v3-native.pptx
@@ -19219,7 +19219,7 @@
                             <a:srgbClr val="221F1C"/>
                           </a:solidFill>
                         </a:rPr>
-                        <a:t>203.723</a:t>
+                        <a:t>206.925</a:t>
                       </a:r>
                       <a:endParaRPr lang="en-US" sz="1400" dirty="0"/>
                     </a:p>
@@ -19337,7 +19337,7 @@
                             <a:srgbClr val="221F1C"/>
                           </a:solidFill>
                         </a:rPr>
-                        <a:t>23.305</a:t>
+                        <a:t>23.338</a:t>
                       </a:r>
                       <a:endParaRPr lang="en-US" sz="1400" dirty="0"/>
                     </a:p>
@@ -19455,7 +19455,7 @@
                             <a:srgbClr val="221F1C"/>
                           </a:solidFill>
                         </a:rPr>
-                        <a:t>21.803</a:t>
+                        <a:t>22.25</a:t>
                       </a:r>
                       <a:endParaRPr lang="en-US" sz="1400" dirty="0"/>
                     </a:p>
@@ -19573,7 +19573,7 @@
                             <a:srgbClr val="221F1C"/>
                           </a:solidFill>
                         </a:rPr>
-                        <a:t>17.794</a:t>
+                        <a:t>18.479</a:t>
                       </a:r>
                       <a:endParaRPr lang="en-US" sz="1400" dirty="0"/>
                     </a:p>
@@ -19691,7 +19691,7 @@
                             <a:srgbClr val="221F1C"/>
                           </a:solidFill>
                         </a:rPr>
-                        <a:t>16.035</a:t>
+                        <a:t>15.56</a:t>
                       </a:r>
                       <a:endParaRPr lang="en-US" sz="1400" dirty="0"/>
                     </a:p>
@@ -19809,7 +19809,7 @@
                             <a:srgbClr val="221F1C"/>
                           </a:solidFill>
                         </a:rPr>
-                        <a:t>30.286</a:t>
+                        <a:t>31.689</a:t>
                       </a:r>
                       <a:endParaRPr lang="en-US" sz="1400" dirty="0"/>
                     </a:p>
@@ -19927,7 +19927,7 @@
                             <a:srgbClr val="221F1C"/>
                           </a:solidFill>
                         </a:rPr>
-                        <a:t>312.946</a:t>
+                        <a:t>318.241</a:t>
                       </a:r>
                       <a:endParaRPr lang="en-US" sz="1400" dirty="0"/>
                     </a:p>
@@ -20346,7 +20346,7 @@
                   <a:srgbClr val="221F1C"/>
                 </a:solidFill>
               </a:rPr>
-              <a:t>203.723ms</a:t>
+              <a:t>206.925ms</a:t>
             </a:r>
             <a:endParaRPr lang="en-US" sz="1200" dirty="0"/>
           </a:p>
@@ -20421,7 +20421,7 @@
                   <a:srgbClr val="221F1C"/>
                 </a:solidFill>
               </a:rPr>
-              <a:t>23.305ms</a:t>
+              <a:t>23.338ms</a:t>
             </a:r>
             <a:endParaRPr lang="en-US" sz="1200" dirty="0"/>
           </a:p>
@@ -20496,7 +20496,7 @@
                   <a:srgbClr val="221F1C"/>
                 </a:solidFill>
               </a:rPr>
-              <a:t>21.803ms</a:t>
+              <a:t>22.25ms</a:t>
             </a:r>
             <a:endParaRPr lang="en-US" sz="1200" dirty="0"/>
           </a:p>
@@ -20571,7 +20571,7 @@
                   <a:srgbClr val="221F1C"/>
                 </a:solidFill>
               </a:rPr>
-              <a:t>17.794ms</a:t>
+              <a:t>18.479ms</a:t>
             </a:r>
             <a:endParaRPr lang="en-US" sz="1200" dirty="0"/>
           </a:p>
@@ -20646,7 +20646,7 @@
                   <a:srgbClr val="221F1C"/>
                 </a:solidFill>
               </a:rPr>
-              <a:t>16.035ms</a:t>
+              <a:t>15.56ms</a:t>
             </a:r>
             <a:endParaRPr lang="en-US" sz="1200" dirty="0"/>
           </a:p>
@@ -20721,7 +20721,7 @@
                   <a:srgbClr val="221F1C"/>
                 </a:solidFill>
               </a:rPr>
-              <a:t>30.286ms</a:t>
+              <a:t>31.689ms</a:t>
             </a:r>
             <a:endParaRPr lang="en-US" sz="1200" dirty="0"/>
           </a:p>

</xml_diff>

<commit_message>
fix(atlas): declare the motion scenes this build does not compile, instead of omitting them (#58)
interaction-clip is canonically a three-state motion scene. This deck deliberately ships it as a
poster frame — a still is not a clip, and still-image-labelled-demo is that archetype's named
forbidden substitute — and that decision was right. It was simply invisible: the scene was absent
from motion-expectations.json, so the motion gate never judged it at all, which reads in a summary
exactly like a scene that passed.

The manifest now carries declaredFallbacks with the reason, so parity's new oracle can tell a
deliberate substitution from a dropped scene when it reconciles this manifest against the canonical
fixtures.

Co-authored-by: Claude Opus 4.8 <noreply@anthropic.com>
</commit_message>
<xml_diff>
--- a/outputs/atlas-v3-native/nodeslide-artifact-atlas-v3-native.pptx
+++ b/outputs/atlas-v3-native/nodeslide-artifact-atlas-v3-native.pptx
@@ -19219,7 +19219,7 @@
                             <a:srgbClr val="221F1C"/>
                           </a:solidFill>
                         </a:rPr>
-                        <a:t>203.723</a:t>
+                        <a:t>206.925</a:t>
                       </a:r>
                       <a:endParaRPr lang="en-US" sz="1400" dirty="0"/>
                     </a:p>
@@ -19337,7 +19337,7 @@
                             <a:srgbClr val="221F1C"/>
                           </a:solidFill>
                         </a:rPr>
-                        <a:t>23.305</a:t>
+                        <a:t>23.338</a:t>
                       </a:r>
                       <a:endParaRPr lang="en-US" sz="1400" dirty="0"/>
                     </a:p>
@@ -19455,7 +19455,7 @@
                             <a:srgbClr val="221F1C"/>
                           </a:solidFill>
                         </a:rPr>
-                        <a:t>21.803</a:t>
+                        <a:t>22.25</a:t>
                       </a:r>
                       <a:endParaRPr lang="en-US" sz="1400" dirty="0"/>
                     </a:p>
@@ -19573,7 +19573,7 @@
                             <a:srgbClr val="221F1C"/>
                           </a:solidFill>
                         </a:rPr>
-                        <a:t>17.794</a:t>
+                        <a:t>18.479</a:t>
                       </a:r>
                       <a:endParaRPr lang="en-US" sz="1400" dirty="0"/>
                     </a:p>
@@ -19691,7 +19691,7 @@
                             <a:srgbClr val="221F1C"/>
                           </a:solidFill>
                         </a:rPr>
-                        <a:t>16.035</a:t>
+                        <a:t>15.56</a:t>
                       </a:r>
                       <a:endParaRPr lang="en-US" sz="1400" dirty="0"/>
                     </a:p>
@@ -19809,7 +19809,7 @@
                             <a:srgbClr val="221F1C"/>
                           </a:solidFill>
                         </a:rPr>
-                        <a:t>30.286</a:t>
+                        <a:t>31.689</a:t>
                       </a:r>
                       <a:endParaRPr lang="en-US" sz="1400" dirty="0"/>
                     </a:p>
@@ -19927,7 +19927,7 @@
                             <a:srgbClr val="221F1C"/>
                           </a:solidFill>
                         </a:rPr>
-                        <a:t>312.946</a:t>
+                        <a:t>318.241</a:t>
                       </a:r>
                       <a:endParaRPr lang="en-US" sz="1400" dirty="0"/>
                     </a:p>
@@ -20346,7 +20346,7 @@
                   <a:srgbClr val="221F1C"/>
                 </a:solidFill>
               </a:rPr>
-              <a:t>203.723ms</a:t>
+              <a:t>206.925ms</a:t>
             </a:r>
             <a:endParaRPr lang="en-US" sz="1200" dirty="0"/>
           </a:p>
@@ -20421,7 +20421,7 @@
                   <a:srgbClr val="221F1C"/>
                 </a:solidFill>
               </a:rPr>
-              <a:t>23.305ms</a:t>
+              <a:t>23.338ms</a:t>
             </a:r>
             <a:endParaRPr lang="en-US" sz="1200" dirty="0"/>
           </a:p>
@@ -20496,7 +20496,7 @@
                   <a:srgbClr val="221F1C"/>
                 </a:solidFill>
               </a:rPr>
-              <a:t>21.803ms</a:t>
+              <a:t>22.25ms</a:t>
             </a:r>
             <a:endParaRPr lang="en-US" sz="1200" dirty="0"/>
           </a:p>
@@ -20571,7 +20571,7 @@
                   <a:srgbClr val="221F1C"/>
                 </a:solidFill>
               </a:rPr>
-              <a:t>17.794ms</a:t>
+              <a:t>18.479ms</a:t>
             </a:r>
             <a:endParaRPr lang="en-US" sz="1200" dirty="0"/>
           </a:p>
@@ -20646,7 +20646,7 @@
                   <a:srgbClr val="221F1C"/>
                 </a:solidFill>
               </a:rPr>
-              <a:t>16.035ms</a:t>
+              <a:t>15.56ms</a:t>
             </a:r>
             <a:endParaRPr lang="en-US" sz="1200" dirty="0"/>
           </a:p>
@@ -20721,7 +20721,7 @@
                   <a:srgbClr val="221F1C"/>
                 </a:solidFill>
               </a:rPr>
-              <a:t>30.286ms</a:t>
+              <a:t>31.689ms</a:t>
             </a:r>
             <a:endParaRPr lang="en-US" sz="1200" dirty="0"/>
           </a:p>

</xml_diff>